<commit_message>
feat(pptx): bump the deck schema to 2.3 for run kern thresholds
A 2.2 session carries no kern, so it is migrated with kernPendingSource
and recovers run and inherited thresholds from its source, the way
spacing and baselines were. Older builds now refuse a 2.3 deck instead
of seeding kerned decks differently from newer ones.

Co-Authored-By: Claude Opus 5.5 <noreply@anthropic.com>
</commit_message>
<xml_diff>
--- a/crates/pptx-edit/tests/fixtures/run-kern.pptx
+++ b/crates/pptx-edit/tests/fixtures/run-kern.pptx
@@ -248,7 +248,11 @@
           <a:bodyPr lIns="0" rIns="0" tIns="0" bIns="0">
             <a:noAutofit/>
           </a:bodyPr>
-          <a:lstStyle/>
+          <a:lstStyle>
+            <a:lvl1pPr>
+              <a:defRPr kern="0"/>
+            </a:lvl1pPr>
+          </a:lstStyle>
           <a:p>
             <a:pPr/>
             <a:r>

</xml_diff>